<commit_message>
Update presentation with held-out test results, ROC/confusion plots
- Results table: 5 rows covering baseline through calibrated + paper target
- Added stenosis ROC curve and confusion matrix images to results slide
- Roadmap: reflects completed calibration, next v7 training plan

Co-Authored-By: Claude Opus 4.6 <noreply@anthropic.com>
</commit_message>
<xml_diff>
--- a/SC_Net_Progress_Update.pptx
+++ b/SC_Net_Progress_Update.pptx
@@ -4732,7 +4732,7 @@
         </p:nvGraphicFramePr>
         <p:xfrm>
           <a:off x="731520" y="1280160"/>
-          <a:ext cx="10515600" cy="1828800"/>
+          <a:ext cx="10515600" cy="2560320"/>
         </p:xfrm>
         <a:graphic>
           <a:graphicData uri="http://schemas.openxmlformats.org/drawingml/2006/table">
@@ -4741,14 +4741,14 @@
                 <a:tableStyleId>{5C22544A-7EE6-4342-B048-85BDC9FD1C3A}</a:tableStyleId>
               </a:tblPr>
               <a:tblGrid>
-                <a:gridCol w="1371600"/>
-                <a:gridCol w="1828800"/>
-                <a:gridCol w="1828800"/>
-                <a:gridCol w="1828800"/>
-                <a:gridCol w="1645920"/>
-                <a:gridCol w="2011680"/>
+                <a:gridCol w="2377440"/>
+                <a:gridCol w="1463040"/>
+                <a:gridCol w="1463040"/>
+                <a:gridCol w="1463040"/>
+                <a:gridCol w="1463040"/>
+                <a:gridCol w="2286000"/>
               </a:tblGrid>
-              <a:tr h="457200">
+              <a:tr h="426720">
                 <a:tc>
                   <a:txBody>
                     <a:bodyPr/>
@@ -4811,7 +4811,7 @@
                         </a:defRPr>
                       </a:pPr>
                       <a:r>
-                        <a:t>Stenosis F1</a:t>
+                        <a:t>Macro F1</a:t>
                       </a:r>
                     </a:p>
                   </a:txBody>
@@ -4835,7 +4835,7 @@
                         </a:defRPr>
                       </a:pPr>
                       <a:r>
-                        <a:t>Stenosis AUC</a:t>
+                        <a:t>Sig. F1</a:t>
                       </a:r>
                     </a:p>
                   </a:txBody>
@@ -4859,7 +4859,7 @@
                         </a:defRPr>
                       </a:pPr>
                       <a:r>
-                        <a:t>Plaque ACC</a:t>
+                        <a:t>Macro AUC</a:t>
                       </a:r>
                     </a:p>
                   </a:txBody>
@@ -4894,7 +4894,7 @@
                   </a:tcPr>
                 </a:tc>
               </a:tr>
-              <a:tr h="457200">
+              <a:tr h="426720">
                 <a:tc>
                   <a:txBody>
                     <a:bodyPr/>
@@ -4909,7 +4909,7 @@
                         </a:defRPr>
                       </a:pPr>
                       <a:r>
-                        <a:t>v2-ft</a:t>
+                        <a:t>v2-ft (baseline)</a:t>
                       </a:r>
                     </a:p>
                   </a:txBody>
@@ -4957,7 +4957,31 @@
                         </a:defRPr>
                       </a:pPr>
                       <a:r>
-                        <a:t>—</a:t>
+                        <a:t>0.160</a:t>
+                      </a:r>
+                    </a:p>
+                  </a:txBody>
+                  <a:tcPr anchor="ctr">
+                    <a:solidFill>
+                      <a:srgbClr val="1E4266"/>
+                    </a:solidFill>
+                  </a:tcPr>
+                </a:tc>
+                <a:tc>
+                  <a:txBody>
+                    <a:bodyPr/>
+                    <a:lstStyle/>
+                    <a:p>
+                      <a:pPr algn="ctr">
+                        <a:defRPr sz="1400">
+                          <a:solidFill>
+                            <a:srgbClr val="DDE4ED"/>
+                          </a:solidFill>
+                          <a:latin typeface="Calibri"/>
+                        </a:defRPr>
+                      </a:pPr>
+                      <a:r>
+                        <a:t>0.000</a:t>
                       </a:r>
                     </a:p>
                   </a:txBody>
@@ -5005,7 +5029,7 @@
                         </a:defRPr>
                       </a:pPr>
                       <a:r>
-                        <a:t>0.630</a:t>
+                        <a:t>Majority class only</a:t>
                       </a:r>
                     </a:p>
                   </a:txBody>
@@ -5015,6 +5039,8 @@
                     </a:solidFill>
                   </a:tcPr>
                 </a:tc>
+              </a:tr>
+              <a:tr h="426720">
                 <a:tc>
                   <a:txBody>
                     <a:bodyPr/>
@@ -5029,33 +5055,7 @@
                         </a:defRPr>
                       </a:pPr>
                       <a:r>
-                        <a:t>Majority class only</a:t>
-                      </a:r>
-                    </a:p>
-                  </a:txBody>
-                  <a:tcPr anchor="ctr">
-                    <a:solidFill>
-                      <a:srgbClr val="1E4266"/>
-                    </a:solidFill>
-                  </a:tcPr>
-                </a:tc>
-              </a:tr>
-              <a:tr h="457200">
-                <a:tc>
-                  <a:txBody>
-                    <a:bodyPr/>
-                    <a:lstStyle/>
-                    <a:p>
-                      <a:pPr algn="ctr">
-                        <a:defRPr sz="1400">
-                          <a:solidFill>
-                            <a:srgbClr val="DDE4ED"/>
-                          </a:solidFill>
-                          <a:latin typeface="Calibri"/>
-                        </a:defRPr>
-                      </a:pPr>
-                      <a:r>
-                        <a:t>v6-ft (ep. 9)</a:t>
+                        <a:t>v6-ft (argmax)</a:t>
                       </a:r>
                     </a:p>
                   </a:txBody>
@@ -5127,6 +5127,30 @@
                         </a:defRPr>
                       </a:pPr>
                       <a:r>
+                        <a:t>0.000</a:t>
+                      </a:r>
+                    </a:p>
+                  </a:txBody>
+                  <a:tcPr anchor="ctr">
+                    <a:solidFill>
+                      <a:srgbClr val="1E4266"/>
+                    </a:solidFill>
+                  </a:tcPr>
+                </a:tc>
+                <a:tc>
+                  <a:txBody>
+                    <a:bodyPr/>
+                    <a:lstStyle/>
+                    <a:p>
+                      <a:pPr algn="ctr">
+                        <a:defRPr sz="1400">
+                          <a:solidFill>
+                            <a:srgbClr val="DDE4ED"/>
+                          </a:solidFill>
+                          <a:latin typeface="Calibri"/>
+                        </a:defRPr>
+                      </a:pPr>
+                      <a:r>
                         <a:t>0.645</a:t>
                       </a:r>
                     </a:p>
@@ -5151,31 +5175,7 @@
                         </a:defRPr>
                       </a:pPr>
                       <a:r>
-                        <a:t>0.567</a:t>
-                      </a:r>
-                    </a:p>
-                  </a:txBody>
-                  <a:tcPr anchor="ctr">
-                    <a:solidFill>
-                      <a:srgbClr val="1E4266"/>
-                    </a:solidFill>
-                  </a:tcPr>
-                </a:tc>
-                <a:tc>
-                  <a:txBody>
-                    <a:bodyPr/>
-                    <a:lstStyle/>
-                    <a:p>
-                      <a:pPr algn="ctr">
-                        <a:defRPr sz="1400">
-                          <a:solidFill>
-                            <a:srgbClr val="DDE4ED"/>
-                          </a:solidFill>
-                          <a:latin typeface="Calibri"/>
-                        </a:defRPr>
-                      </a:pPr>
-                      <a:r>
-                        <a:t>First class discrimination</a:t>
+                        <a:t>Zero Sig. predictions</a:t>
                       </a:r>
                     </a:p>
                   </a:txBody>
@@ -5186,7 +5186,299 @@
                   </a:tcPr>
                 </a:tc>
               </a:tr>
-              <a:tr h="457200">
+              <a:tr h="426720">
+                <a:tc>
+                  <a:txBody>
+                    <a:bodyPr/>
+                    <a:lstStyle/>
+                    <a:p>
+                      <a:pPr algn="ctr">
+                        <a:defRPr sz="1400" b="1">
+                          <a:solidFill>
+                            <a:srgbClr val="FFFFFF"/>
+                          </a:solidFill>
+                          <a:latin typeface="Calibri"/>
+                        </a:defRPr>
+                      </a:pPr>
+                      <a:r>
+                        <a:t>v6-ft (calibrated)</a:t>
+                      </a:r>
+                    </a:p>
+                  </a:txBody>
+                  <a:tcPr anchor="ctr">
+                    <a:solidFill>
+                      <a:srgbClr val="244E78"/>
+                    </a:solidFill>
+                  </a:tcPr>
+                </a:tc>
+                <a:tc>
+                  <a:txBody>
+                    <a:bodyPr/>
+                    <a:lstStyle/>
+                    <a:p>
+                      <a:pPr algn="ctr">
+                        <a:defRPr sz="1400" b="1">
+                          <a:solidFill>
+                            <a:srgbClr val="FFFFFF"/>
+                          </a:solidFill>
+                          <a:latin typeface="Calibri"/>
+                        </a:defRPr>
+                      </a:pPr>
+                      <a:r>
+                        <a:t>0.470</a:t>
+                      </a:r>
+                    </a:p>
+                  </a:txBody>
+                  <a:tcPr anchor="ctr">
+                    <a:solidFill>
+                      <a:srgbClr val="244E78"/>
+                    </a:solidFill>
+                  </a:tcPr>
+                </a:tc>
+                <a:tc>
+                  <a:txBody>
+                    <a:bodyPr/>
+                    <a:lstStyle/>
+                    <a:p>
+                      <a:pPr algn="ctr">
+                        <a:defRPr sz="1400" b="1">
+                          <a:solidFill>
+                            <a:srgbClr val="FFFFFF"/>
+                          </a:solidFill>
+                          <a:latin typeface="Calibri"/>
+                        </a:defRPr>
+                      </a:pPr>
+                      <a:r>
+                        <a:t>0.417</a:t>
+                      </a:r>
+                    </a:p>
+                  </a:txBody>
+                  <a:tcPr anchor="ctr">
+                    <a:solidFill>
+                      <a:srgbClr val="244E78"/>
+                    </a:solidFill>
+                  </a:tcPr>
+                </a:tc>
+                <a:tc>
+                  <a:txBody>
+                    <a:bodyPr/>
+                    <a:lstStyle/>
+                    <a:p>
+                      <a:pPr algn="ctr">
+                        <a:defRPr sz="1400" b="1">
+                          <a:solidFill>
+                            <a:srgbClr val="FFFFFF"/>
+                          </a:solidFill>
+                          <a:latin typeface="Calibri"/>
+                        </a:defRPr>
+                      </a:pPr>
+                      <a:r>
+                        <a:t>0.621</a:t>
+                      </a:r>
+                    </a:p>
+                  </a:txBody>
+                  <a:tcPr anchor="ctr">
+                    <a:solidFill>
+                      <a:srgbClr val="244E78"/>
+                    </a:solidFill>
+                  </a:tcPr>
+                </a:tc>
+                <a:tc>
+                  <a:txBody>
+                    <a:bodyPr/>
+                    <a:lstStyle/>
+                    <a:p>
+                      <a:pPr algn="ctr">
+                        <a:defRPr sz="1400" b="1">
+                          <a:solidFill>
+                            <a:srgbClr val="FFFFFF"/>
+                          </a:solidFill>
+                          <a:latin typeface="Calibri"/>
+                        </a:defRPr>
+                      </a:pPr>
+                      <a:r>
+                        <a:t>0.645</a:t>
+                      </a:r>
+                    </a:p>
+                  </a:txBody>
+                  <a:tcPr anchor="ctr">
+                    <a:solidFill>
+                      <a:srgbClr val="244E78"/>
+                    </a:solidFill>
+                  </a:tcPr>
+                </a:tc>
+                <a:tc>
+                  <a:txBody>
+                    <a:bodyPr/>
+                    <a:lstStyle/>
+                    <a:p>
+                      <a:pPr algn="ctr">
+                        <a:defRPr sz="1400" b="1">
+                          <a:solidFill>
+                            <a:srgbClr val="FFFFFF"/>
+                          </a:solidFill>
+                          <a:latin typeface="Calibri"/>
+                        </a:defRPr>
+                      </a:pPr>
+                      <a:r>
+                        <a:t>Best result (val split)</a:t>
+                      </a:r>
+                    </a:p>
+                  </a:txBody>
+                  <a:tcPr anchor="ctr">
+                    <a:solidFill>
+                      <a:srgbClr val="244E78"/>
+                    </a:solidFill>
+                  </a:tcPr>
+                </a:tc>
+              </a:tr>
+              <a:tr h="426720">
+                <a:tc>
+                  <a:txBody>
+                    <a:bodyPr/>
+                    <a:lstStyle/>
+                    <a:p>
+                      <a:pPr algn="ctr">
+                        <a:defRPr sz="1400" b="1">
+                          <a:solidFill>
+                            <a:srgbClr val="FFFFFF"/>
+                          </a:solidFill>
+                          <a:latin typeface="Calibri"/>
+                        </a:defRPr>
+                      </a:pPr>
+                      <a:r>
+                        <a:t>v6-ft (held-out, cal.)</a:t>
+                      </a:r>
+                    </a:p>
+                  </a:txBody>
+                  <a:tcPr anchor="ctr">
+                    <a:solidFill>
+                      <a:srgbClr val="244E78"/>
+                    </a:solidFill>
+                  </a:tcPr>
+                </a:tc>
+                <a:tc>
+                  <a:txBody>
+                    <a:bodyPr/>
+                    <a:lstStyle/>
+                    <a:p>
+                      <a:pPr algn="ctr">
+                        <a:defRPr sz="1400" b="1">
+                          <a:solidFill>
+                            <a:srgbClr val="FFFFFF"/>
+                          </a:solidFill>
+                          <a:latin typeface="Calibri"/>
+                        </a:defRPr>
+                      </a:pPr>
+                      <a:r>
+                        <a:t>0.435</a:t>
+                      </a:r>
+                    </a:p>
+                  </a:txBody>
+                  <a:tcPr anchor="ctr">
+                    <a:solidFill>
+                      <a:srgbClr val="244E78"/>
+                    </a:solidFill>
+                  </a:tcPr>
+                </a:tc>
+                <a:tc>
+                  <a:txBody>
+                    <a:bodyPr/>
+                    <a:lstStyle/>
+                    <a:p>
+                      <a:pPr algn="ctr">
+                        <a:defRPr sz="1400" b="1">
+                          <a:solidFill>
+                            <a:srgbClr val="FFFFFF"/>
+                          </a:solidFill>
+                          <a:latin typeface="Calibri"/>
+                        </a:defRPr>
+                      </a:pPr>
+                      <a:r>
+                        <a:t>0.393</a:t>
+                      </a:r>
+                    </a:p>
+                  </a:txBody>
+                  <a:tcPr anchor="ctr">
+                    <a:solidFill>
+                      <a:srgbClr val="244E78"/>
+                    </a:solidFill>
+                  </a:tcPr>
+                </a:tc>
+                <a:tc>
+                  <a:txBody>
+                    <a:bodyPr/>
+                    <a:lstStyle/>
+                    <a:p>
+                      <a:pPr algn="ctr">
+                        <a:defRPr sz="1400" b="1">
+                          <a:solidFill>
+                            <a:srgbClr val="FFFFFF"/>
+                          </a:solidFill>
+                          <a:latin typeface="Calibri"/>
+                        </a:defRPr>
+                      </a:pPr>
+                      <a:r>
+                        <a:t>0.525</a:t>
+                      </a:r>
+                    </a:p>
+                  </a:txBody>
+                  <a:tcPr anchor="ctr">
+                    <a:solidFill>
+                      <a:srgbClr val="244E78"/>
+                    </a:solidFill>
+                  </a:tcPr>
+                </a:tc>
+                <a:tc>
+                  <a:txBody>
+                    <a:bodyPr/>
+                    <a:lstStyle/>
+                    <a:p>
+                      <a:pPr algn="ctr">
+                        <a:defRPr sz="1400" b="1">
+                          <a:solidFill>
+                            <a:srgbClr val="FFFFFF"/>
+                          </a:solidFill>
+                          <a:latin typeface="Calibri"/>
+                        </a:defRPr>
+                      </a:pPr>
+                      <a:r>
+                        <a:t>0.604</a:t>
+                      </a:r>
+                    </a:p>
+                  </a:txBody>
+                  <a:tcPr anchor="ctr">
+                    <a:solidFill>
+                      <a:srgbClr val="244E78"/>
+                    </a:solidFill>
+                  </a:tcPr>
+                </a:tc>
+                <a:tc>
+                  <a:txBody>
+                    <a:bodyPr/>
+                    <a:lstStyle/>
+                    <a:p>
+                      <a:pPr algn="ctr">
+                        <a:defRPr sz="1400" b="1">
+                          <a:solidFill>
+                            <a:srgbClr val="FFFFFF"/>
+                          </a:solidFill>
+                          <a:latin typeface="Calibri"/>
+                        </a:defRPr>
+                      </a:pPr>
+                      <a:r>
+                        <a:t>Unseen AP-NUH patients</a:t>
+                      </a:r>
+                    </a:p>
+                  </a:txBody>
+                  <a:tcPr anchor="ctr">
+                    <a:solidFill>
+                      <a:srgbClr val="244E78"/>
+                    </a:solidFill>
+                  </a:tcPr>
+                </a:tc>
+              </a:tr>
+              <a:tr h="426720">
                 <a:tc>
                   <a:txBody>
                     <a:bodyPr/>
@@ -5225,7 +5517,7 @@
                         </a:defRPr>
                       </a:pPr>
                       <a:r>
-                        <a:t>0.928</a:t>
+                        <a:t>0.914</a:t>
                       </a:r>
                     </a:p>
                   </a:txBody>
@@ -5249,7 +5541,7 @@
                         </a:defRPr>
                       </a:pPr>
                       <a:r>
-                        <a:t>0.944</a:t>
+                        <a:t>—</a:t>
                       </a:r>
                     </a:p>
                   </a:txBody>
@@ -5344,8 +5636,8 @@
         </p:nvSpPr>
         <p:spPr>
           <a:xfrm>
-            <a:off x="731520" y="3383280"/>
-            <a:ext cx="5029200" cy="2103120"/>
+            <a:off x="731520" y="4114800"/>
+            <a:ext cx="4572000" cy="2468880"/>
           </a:xfrm>
           <a:prstGeom prst="rect">
             <a:avLst/>
@@ -5389,8 +5681,8 @@
         </p:nvSpPr>
         <p:spPr>
           <a:xfrm>
-            <a:off x="914400" y="3474720"/>
-            <a:ext cx="4572000" cy="457200"/>
+            <a:off x="914400" y="4206240"/>
+            <a:ext cx="4206240" cy="457200"/>
           </a:xfrm>
           <a:prstGeom prst="rect">
             <a:avLst/>
@@ -5412,7 +5704,7 @@
               </a:defRPr>
             </a:pPr>
             <a:r>
-              <a:t>Key Finding: Calibration Problem, Not Learning Failure</a:t>
+              <a:t>Calibration Impact (Held-Out Test)</a:t>
             </a:r>
           </a:p>
         </p:txBody>
@@ -5425,8 +5717,8 @@
         </p:nvSpPr>
         <p:spPr>
           <a:xfrm>
-            <a:off x="914400" y="3886200"/>
-            <a:ext cx="4572000" cy="1463040"/>
+            <a:off x="914400" y="4617720"/>
+            <a:ext cx="4206240" cy="1828800"/>
           </a:xfrm>
           <a:prstGeom prst="rect">
             <a:avLst/>
@@ -5441,9 +5733,9 @@
           <a:p>
             <a:pPr>
               <a:spcAft>
-                <a:spcPts val="300"/>
+                <a:spcPts val="200"/>
               </a:spcAft>
-              <a:defRPr sz="1300">
+              <a:defRPr sz="1200">
                 <a:solidFill>
                   <a:srgbClr val="CCD5E0"/>
                 </a:solidFill>
@@ -5451,15 +5743,15 @@
               </a:defRPr>
             </a:pPr>
             <a:r>
-              <a:t>•  Significant-class AUC = 0.748 — strong internal discrimination</a:t>
+              <a:t>•  Significant AUC = 0.707 — model discriminates internally</a:t>
             </a:r>
           </a:p>
           <a:p>
             <a:pPr>
               <a:spcAft>
-                <a:spcPts val="300"/>
+                <a:spcPts val="200"/>
               </a:spcAft>
-              <a:defRPr sz="1300">
+              <a:defRPr sz="1200">
                 <a:solidFill>
                   <a:srgbClr val="CCD5E0"/>
                 </a:solidFill>
@@ -5467,15 +5759,15 @@
               </a:defRPr>
             </a:pPr>
             <a:r>
-              <a:t>•  Model ranks Significant cases higher than Non-significant</a:t>
+              <a:t>•  Argmax: zero Significant predictions (boundary misaligned)</a:t>
             </a:r>
           </a:p>
           <a:p>
             <a:pPr>
               <a:spcAft>
-                <a:spcPts val="300"/>
+                <a:spcPts val="200"/>
               </a:spcAft>
-              <a:defRPr sz="1300">
+              <a:defRPr sz="1200">
                 <a:solidFill>
                   <a:srgbClr val="CCD5E0"/>
                 </a:solidFill>
@@ -5483,15 +5775,15 @@
               </a:defRPr>
             </a:pPr>
             <a:r>
-              <a:t>•  But: zero argmax predictions for Significant class</a:t>
+              <a:t>•  Thresholds: H=3.0, NS=1.0, Sig=0.346</a:t>
             </a:r>
           </a:p>
           <a:p>
             <a:pPr>
               <a:spcAft>
-                <a:spcPts val="300"/>
+                <a:spcPts val="200"/>
               </a:spcAft>
-              <a:defRPr sz="1300">
+              <a:defRPr sz="1200">
                 <a:solidFill>
                   <a:srgbClr val="CCD5E0"/>
                 </a:solidFill>
@@ -5499,15 +5791,15 @@
               </a:defRPr>
             </a:pPr>
             <a:r>
-              <a:t>•  Diagnosis: Decision boundary misaligned (calibration issue)</a:t>
+              <a:t>•  Significant F1: 0.000 → 0.525 (no retraining)</a:t>
             </a:r>
           </a:p>
           <a:p>
             <a:pPr>
               <a:spcAft>
-                <a:spcPts val="300"/>
+                <a:spcPts val="200"/>
               </a:spcAft>
-              <a:defRPr sz="1300">
+              <a:defRPr sz="1200">
                 <a:solidFill>
                   <a:srgbClr val="CCD5E0"/>
                 </a:solidFill>
@@ -5515,231 +5807,75 @@
               </a:defRPr>
             </a:pPr>
             <a:r>
-              <a:t>•  Fixable without retraining via post-hoc threshold tuning</a:t>
-            </a:r>
-          </a:p>
-        </p:txBody>
-      </p:sp>
-      <p:sp>
-        <p:nvSpPr>
-          <p:cNvPr id="9" name="Rectangle 8"/>
-          <p:cNvSpPr/>
+              <a:t>•  Macro F1: 0.210 → 0.393 (+87%)</a:t>
+            </a:r>
+          </a:p>
+          <a:p>
+            <a:pPr>
+              <a:spcAft>
+                <a:spcPts val="200"/>
+              </a:spcAft>
+              <a:defRPr sz="1200">
+                <a:solidFill>
+                  <a:srgbClr val="CCD5E0"/>
+                </a:solidFill>
+                <a:latin typeface="Calibri"/>
+              </a:defRPr>
+            </a:pPr>
+            <a:r>
+              <a:t>•  Plaque AUC ≈ 0.55 (near chance) — needs training fixes</a:t>
+            </a:r>
+          </a:p>
+        </p:txBody>
+      </p:sp>
+      <p:pic>
+        <p:nvPicPr>
+          <p:cNvPr id="9" name="Picture 8" descr="roc_stenosis.png"/>
+          <p:cNvPicPr>
+            <a:picLocks noChangeAspect="1"/>
+          </p:cNvPicPr>
           <p:nvPr/>
-        </p:nvSpPr>
-        <p:spPr>
-          <a:xfrm>
-            <a:off x="6217920" y="3383280"/>
-            <a:ext cx="5029200" cy="2103120"/>
+        </p:nvPicPr>
+        <p:blipFill>
+          <a:blip r:embed="rId2"/>
+          <a:stretch>
+            <a:fillRect/>
+          </a:stretch>
+        </p:blipFill>
+        <p:spPr>
+          <a:xfrm>
+            <a:off x="5669280" y="4114800"/>
+            <a:ext cx="3108960" cy="2468880"/>
           </a:xfrm>
           <a:prstGeom prst="rect">
             <a:avLst/>
           </a:prstGeom>
-          <a:solidFill>
-            <a:srgbClr val="244E78"/>
-          </a:solidFill>
-          <a:ln w="12700">
-            <a:solidFill>
-              <a:srgbClr val="3A7CBD"/>
-            </a:solidFill>
-          </a:ln>
-        </p:spPr>
-        <p:style>
-          <a:lnRef idx="1">
-            <a:schemeClr val="accent1"/>
-          </a:lnRef>
-          <a:fillRef idx="3">
-            <a:schemeClr val="accent1"/>
-          </a:fillRef>
-          <a:effectRef idx="2">
-            <a:schemeClr val="accent1"/>
-          </a:effectRef>
-          <a:fontRef idx="minor">
-            <a:schemeClr val="lt1"/>
-          </a:fontRef>
-        </p:style>
-        <p:txBody>
-          <a:bodyPr rtlCol="0" anchor="ctr"/>
-          <a:lstStyle/>
-          <a:p>
-            <a:pPr algn="ctr"/>
-          </a:p>
-        </p:txBody>
-      </p:sp>
-      <p:sp>
-        <p:nvSpPr>
-          <p:cNvPr id="10" name="TextBox 9"/>
-          <p:cNvSpPr txBox="1"/>
+        </p:spPr>
+      </p:pic>
+      <p:pic>
+        <p:nvPicPr>
+          <p:cNvPr id="10" name="Picture 9" descr="confusion_stenosis.png"/>
+          <p:cNvPicPr>
+            <a:picLocks noChangeAspect="1"/>
+          </p:cNvPicPr>
           <p:nvPr/>
-        </p:nvSpPr>
-        <p:spPr>
-          <a:xfrm>
-            <a:off x="6400800" y="3474720"/>
-            <a:ext cx="4572000" cy="457200"/>
+        </p:nvPicPr>
+        <p:blipFill>
+          <a:blip r:embed="rId3"/>
+          <a:stretch>
+            <a:fillRect/>
+          </a:stretch>
+        </p:blipFill>
+        <p:spPr>
+          <a:xfrm>
+            <a:off x="8961120" y="4114800"/>
+            <a:ext cx="2926080" cy="2468880"/>
           </a:xfrm>
           <a:prstGeom prst="rect">
             <a:avLst/>
           </a:prstGeom>
-          <a:noFill/>
-        </p:spPr>
-        <p:txBody>
-          <a:bodyPr wrap="square">
-            <a:spAutoFit/>
-          </a:bodyPr>
-          <a:lstStyle/>
-          <a:p>
-            <a:pPr algn="l">
-              <a:defRPr sz="1600" b="1">
-                <a:solidFill>
-                  <a:srgbClr val="3A7CBD"/>
-                </a:solidFill>
-                <a:latin typeface="Calibri"/>
-              </a:defRPr>
-            </a:pPr>
-            <a:r>
-              <a:t>Progress Assessment</a:t>
-            </a:r>
-          </a:p>
-        </p:txBody>
-      </p:sp>
-      <p:sp>
-        <p:nvSpPr>
-          <p:cNvPr id="11" name="TextBox 10"/>
-          <p:cNvSpPr txBox="1"/>
-          <p:nvPr/>
-        </p:nvSpPr>
-        <p:spPr>
-          <a:xfrm>
-            <a:off x="6400800" y="3886200"/>
-            <a:ext cx="4572000" cy="1463040"/>
-          </a:xfrm>
-          <a:prstGeom prst="rect">
-            <a:avLst/>
-          </a:prstGeom>
-          <a:noFill/>
-        </p:spPr>
-        <p:txBody>
-          <a:bodyPr wrap="square">
-            <a:spAutoFit/>
-          </a:bodyPr>
-          <a:lstStyle/>
-          <a:p>
-            <a:pPr>
-              <a:spcAft>
-                <a:spcPts val="300"/>
-              </a:spcAft>
-              <a:defRPr sz="1300">
-                <a:solidFill>
-                  <a:srgbClr val="CCD5E0"/>
-                </a:solidFill>
-                <a:latin typeface="Calibri"/>
-              </a:defRPr>
-            </a:pPr>
-            <a:r>
-              <a:t>•  v6-ft is the first run achieving real class discrimination</a:t>
-            </a:r>
-          </a:p>
-          <a:p>
-            <a:pPr>
-              <a:spcAft>
-                <a:spcPts val="300"/>
-              </a:spcAft>
-              <a:defRPr sz="1300">
-                <a:solidFill>
-                  <a:srgbClr val="CCD5E0"/>
-                </a:solidFill>
-                <a:latin typeface="Calibri"/>
-              </a:defRPr>
-            </a:pPr>
-            <a:r>
-              <a:t>•  v2-ft predicted only majority class (Normal) — no learning</a:t>
-            </a:r>
-          </a:p>
-          <a:p>
-            <a:pPr>
-              <a:spcAft>
-                <a:spcPts val="300"/>
-              </a:spcAft>
-              <a:defRPr sz="1300">
-                <a:solidFill>
-                  <a:srgbClr val="CCD5E0"/>
-                </a:solidFill>
-                <a:latin typeface="Calibri"/>
-              </a:defRPr>
-            </a:pPr>
-            <a:r>
-              <a:t>•  Root cause analysis saved weeks of misdirected effort</a:t>
-            </a:r>
-          </a:p>
-          <a:p>
-            <a:pPr>
-              <a:spcAft>
-                <a:spcPts val="300"/>
-              </a:spcAft>
-              <a:defRPr sz="1300">
-                <a:solidFill>
-                  <a:srgbClr val="CCD5E0"/>
-                </a:solidFill>
-                <a:latin typeface="Calibri"/>
-              </a:defRPr>
-            </a:pPr>
-            <a:r>
-              <a:t>•  AUC improvement: 0.573 → 0.645 (+12.6% relative)</a:t>
-            </a:r>
-          </a:p>
-          <a:p>
-            <a:pPr>
-              <a:spcAft>
-                <a:spcPts val="300"/>
-              </a:spcAft>
-              <a:defRPr sz="1300">
-                <a:solidFill>
-                  <a:srgbClr val="CCD5E0"/>
-                </a:solidFill>
-                <a:latin typeface="Calibri"/>
-              </a:defRPr>
-            </a:pPr>
-            <a:r>
-              <a:t>•  Gap to paper: expected — using ~30% of paper's data volume</a:t>
-            </a:r>
-          </a:p>
-        </p:txBody>
-      </p:sp>
-      <p:sp>
-        <p:nvSpPr>
-          <p:cNvPr id="12" name="TextBox 11"/>
-          <p:cNvSpPr txBox="1"/>
-          <p:nvPr/>
-        </p:nvSpPr>
-        <p:spPr>
-          <a:xfrm>
-            <a:off x="731520" y="5760720"/>
-            <a:ext cx="10058400" cy="457200"/>
-          </a:xfrm>
-          <a:prstGeom prst="rect">
-            <a:avLst/>
-          </a:prstGeom>
-          <a:noFill/>
-        </p:spPr>
-        <p:txBody>
-          <a:bodyPr wrap="square">
-            <a:spAutoFit/>
-          </a:bodyPr>
-          <a:lstStyle/>
-          <a:p>
-            <a:pPr algn="l">
-              <a:defRPr sz="1200" b="0">
-                <a:solidFill>
-                  <a:srgbClr val="6B7B8D"/>
-                </a:solidFill>
-                <a:latin typeface="Calibri"/>
-              </a:defRPr>
-            </a:pPr>
-            <a:r>
-              <a:t>Dataset: ~65 patients (30% of paper's 218). Paper metrics use 100% data with 70/30 train-val split.</a:t>
-            </a:r>
-          </a:p>
-        </p:txBody>
-      </p:sp>
+        </p:spPr>
+      </p:pic>
     </p:spTree>
   </p:cSld>
   <p:clrMapOvr>
@@ -6007,7 +6143,7 @@
               </a:defRPr>
             </a:pPr>
             <a:r>
-              <a:t>Immediate</a:t>
+              <a:t>Completed</a:t>
             </a:r>
           </a:p>
         </p:txBody>
@@ -6048,6 +6184,10 @@
             <a:r>
               <a:t>•  Post-hoc threshold calibration</a:t>
             </a:r>
+            <a:br/>
+            <a:r>
+              <a:t>✔ Sig. F1: 0.000 → 0.525</a:t>
+            </a:r>
           </a:p>
           <a:p>
             <a:pPr>
@@ -6062,11 +6202,11 @@
               </a:defRPr>
             </a:pPr>
             <a:r>
-              <a:t>•  Recover Significant predictions</a:t>
+              <a:t>•  Held-out test evaluation on</a:t>
             </a:r>
             <a:br/>
             <a:r>
-              <a:t>with no retraining required</a:t>
+              <a:t>665 separate AP-NUH patients</a:t>
             </a:r>
           </a:p>
           <a:p>
@@ -6082,11 +6222,11 @@
               </a:defRPr>
             </a:pPr>
             <a:r>
-              <a:t>•  Platt scaling or isotonic</a:t>
+              <a:t>•  Root cause analysis: paper code</a:t>
             </a:r>
             <a:br/>
             <a:r>
-              <a:t>regression on validation set</a:t>
+              <a:t>≠ paper equations (reverted)</a:t>
             </a:r>
           </a:p>
           <a:p>
@@ -6102,11 +6242,11 @@
               </a:defRPr>
             </a:pPr>
             <a:r>
-              <a:t>•  Expected: meaningful F1 gain</a:t>
+              <a:t>•  13+ architecture bug fixes</a:t>
             </a:r>
             <a:br/>
             <a:r>
-              <a:t>from existing model weights</a:t>
+              <a:t>across 6 core files</a:t>
             </a:r>
           </a:p>
         </p:txBody>
@@ -6230,7 +6370,7 @@
               </a:defRPr>
             </a:pPr>
             <a:r>
-              <a:t>Short-Term</a:t>
+              <a:t>Next: v7 Training</a:t>
             </a:r>
           </a:p>
         </p:txBody>
@@ -6329,11 +6469,11 @@
               </a:defRPr>
             </a:pPr>
             <a:r>
-              <a:t>•  Systematic hyperparameter</a:t>
+              <a:t>•  Expected: better convergence,</a:t>
             </a:r>
             <a:br/>
             <a:r>
-              <a:t>search on loss weights</a:t>
+              <a:t>higher AUC across classes</a:t>
             </a:r>
           </a:p>
         </p:txBody>
@@ -6500,7 +6640,7 @@
             </a:r>
             <a:br/>
             <a:r>
-              <a:t>(currently undertrained)</a:t>
+              <a:t>(AUC ≈ 0.55, near chance)</a:t>
             </a:r>
           </a:p>
           <a:p>

</xml_diff>

<commit_message>
Update report and presentation with v7-ft calibrated results
- report.md: fix Phase 9 commit hash, add held-out eval table with
  per-class breakdown, list plots_v7ft_calibrated/ artefacts, and
  update performance summary table to latest numbers
- SC_Net_Progress_Update.pptx: replace results table with v7-ft
  argmax + calibrated rows (Sig F1=0.752, Sig Rec=93.5%, AUC=0.720),
  replace confusion matrix images with plots_v7ft_calibrated PNGs,
  update calibration impact text, and refresh roadmap slide
  (completed v7-ft, next steps target Non-sig stenosis)

Co-Authored-By: Claude Sonnet 4.6 <noreply@anthropic.com>
</commit_message>
<xml_diff>
--- a/SC_Net_Progress_Update.pptx
+++ b/SC_Net_Progress_Update.pptx
@@ -5046,16 +5046,10 @@
                     <a:bodyPr/>
                     <a:lstStyle/>
                     <a:p>
-                      <a:pPr algn="ctr">
-                        <a:defRPr sz="1400">
-                          <a:solidFill>
-                            <a:srgbClr val="DDE4ED"/>
-                          </a:solidFill>
-                          <a:latin typeface="Calibri"/>
-                        </a:defRPr>
-                      </a:pPr>
+                      <a:pPr algn="ctr"/>
                       <a:r>
-                        <a:t>v6-ft (argmax)</a:t>
+                        <a:rPr sz="900" b="0"/>
+                        <a:t>v6-ft (held-out, cal.)</a:t>
                       </a:r>
                     </a:p>
                   </a:txBody>
@@ -5070,16 +5064,10 @@
                     <a:bodyPr/>
                     <a:lstStyle/>
                     <a:p>
-                      <a:pPr algn="ctr">
-                        <a:defRPr sz="1400">
-                          <a:solidFill>
-                            <a:srgbClr val="DDE4ED"/>
-                          </a:solidFill>
-                          <a:latin typeface="Calibri"/>
-                        </a:defRPr>
-                      </a:pPr>
+                      <a:pPr algn="ctr"/>
                       <a:r>
-                        <a:t>0.369</a:t>
+                        <a:rPr sz="900" b="0"/>
+                        <a:t>0.435</a:t>
                       </a:r>
                     </a:p>
                   </a:txBody>
@@ -5094,16 +5082,10 @@
                     <a:bodyPr/>
                     <a:lstStyle/>
                     <a:p>
-                      <a:pPr algn="ctr">
-                        <a:defRPr sz="1400">
-                          <a:solidFill>
-                            <a:srgbClr val="DDE4ED"/>
-                          </a:solidFill>
-                          <a:latin typeface="Calibri"/>
-                        </a:defRPr>
-                      </a:pPr>
+                      <a:pPr algn="ctr"/>
                       <a:r>
-                        <a:t>0.288</a:t>
+                        <a:rPr sz="900" b="0"/>
+                        <a:t>0.393</a:t>
                       </a:r>
                     </a:p>
                   </a:txBody>
@@ -5118,16 +5100,10 @@
                     <a:bodyPr/>
                     <a:lstStyle/>
                     <a:p>
-                      <a:pPr algn="ctr">
-                        <a:defRPr sz="1400">
-                          <a:solidFill>
-                            <a:srgbClr val="DDE4ED"/>
-                          </a:solidFill>
-                          <a:latin typeface="Calibri"/>
-                        </a:defRPr>
-                      </a:pPr>
+                      <a:pPr algn="ctr"/>
                       <a:r>
-                        <a:t>0.000</a:t>
+                        <a:rPr sz="900" b="0"/>
+                        <a:t>0.525</a:t>
                       </a:r>
                     </a:p>
                   </a:txBody>
@@ -5142,16 +5118,10 @@
                     <a:bodyPr/>
                     <a:lstStyle/>
                     <a:p>
-                      <a:pPr algn="ctr">
-                        <a:defRPr sz="1400">
-                          <a:solidFill>
-                            <a:srgbClr val="DDE4ED"/>
-                          </a:solidFill>
-                          <a:latin typeface="Calibri"/>
-                        </a:defRPr>
-                      </a:pPr>
+                      <a:pPr algn="ctr"/>
                       <a:r>
-                        <a:t>0.645</a:t>
+                        <a:rPr sz="900" b="0"/>
+                        <a:t>0.604</a:t>
                       </a:r>
                     </a:p>
                   </a:txBody>
@@ -5166,16 +5136,10 @@
                     <a:bodyPr/>
                     <a:lstStyle/>
                     <a:p>
-                      <a:pPr algn="ctr">
-                        <a:defRPr sz="1400">
-                          <a:solidFill>
-                            <a:srgbClr val="DDE4ED"/>
-                          </a:solidFill>
-                          <a:latin typeface="Calibri"/>
-                        </a:defRPr>
-                      </a:pPr>
+                      <a:pPr algn="ctr"/>
                       <a:r>
-                        <a:t>Zero Sig. predictions</a:t>
+                        <a:rPr sz="900" b="0"/>
+                        <a:t>Best prev. result</a:t>
                       </a:r>
                     </a:p>
                   </a:txBody>
@@ -5192,16 +5156,10 @@
                     <a:bodyPr/>
                     <a:lstStyle/>
                     <a:p>
-                      <a:pPr algn="ctr">
-                        <a:defRPr sz="1400" b="1">
-                          <a:solidFill>
-                            <a:srgbClr val="FFFFFF"/>
-                          </a:solidFill>
-                          <a:latin typeface="Calibri"/>
-                        </a:defRPr>
-                      </a:pPr>
+                      <a:pPr algn="ctr"/>
                       <a:r>
-                        <a:t>v6-ft (calibrated)</a:t>
+                        <a:rPr sz="900" b="0"/>
+                        <a:t>v7-ft (argmax)</a:t>
                       </a:r>
                     </a:p>
                   </a:txBody>
@@ -5216,16 +5174,10 @@
                     <a:bodyPr/>
                     <a:lstStyle/>
                     <a:p>
-                      <a:pPr algn="ctr">
-                        <a:defRPr sz="1400" b="1">
-                          <a:solidFill>
-                            <a:srgbClr val="FFFFFF"/>
-                          </a:solidFill>
-                          <a:latin typeface="Calibri"/>
-                        </a:defRPr>
-                      </a:pPr>
+                      <a:pPr algn="ctr"/>
                       <a:r>
-                        <a:t>0.470</a:t>
+                        <a:rPr sz="900" b="0"/>
+                        <a:t>0.402</a:t>
                       </a:r>
                     </a:p>
                   </a:txBody>
@@ -5240,16 +5192,10 @@
                     <a:bodyPr/>
                     <a:lstStyle/>
                     <a:p>
-                      <a:pPr algn="ctr">
-                        <a:defRPr sz="1400" b="1">
-                          <a:solidFill>
-                            <a:srgbClr val="FFFFFF"/>
-                          </a:solidFill>
-                          <a:latin typeface="Calibri"/>
-                        </a:defRPr>
-                      </a:pPr>
+                      <a:pPr algn="ctr"/>
                       <a:r>
-                        <a:t>0.417</a:t>
+                        <a:rPr sz="900" b="0"/>
+                        <a:t>0.342</a:t>
                       </a:r>
                     </a:p>
                   </a:txBody>
@@ -5264,16 +5210,10 @@
                     <a:bodyPr/>
                     <a:lstStyle/>
                     <a:p>
-                      <a:pPr algn="ctr">
-                        <a:defRPr sz="1400" b="1">
-                          <a:solidFill>
-                            <a:srgbClr val="FFFFFF"/>
-                          </a:solidFill>
-                          <a:latin typeface="Calibri"/>
-                        </a:defRPr>
-                      </a:pPr>
+                      <a:pPr algn="ctr"/>
                       <a:r>
-                        <a:t>0.621</a:t>
+                        <a:rPr sz="900" b="0"/>
+                        <a:t>0.000</a:t>
                       </a:r>
                     </a:p>
                   </a:txBody>
@@ -5288,16 +5228,10 @@
                     <a:bodyPr/>
                     <a:lstStyle/>
                     <a:p>
-                      <a:pPr algn="ctr">
-                        <a:defRPr sz="1400" b="1">
-                          <a:solidFill>
-                            <a:srgbClr val="FFFFFF"/>
-                          </a:solidFill>
-                          <a:latin typeface="Calibri"/>
-                        </a:defRPr>
-                      </a:pPr>
+                      <a:pPr algn="ctr"/>
                       <a:r>
-                        <a:t>0.645</a:t>
+                        <a:rPr sz="900" b="0"/>
+                        <a:t>0.713</a:t>
                       </a:r>
                     </a:p>
                   </a:txBody>
@@ -5312,16 +5246,10 @@
                     <a:bodyPr/>
                     <a:lstStyle/>
                     <a:p>
-                      <a:pPr algn="ctr">
-                        <a:defRPr sz="1400" b="1">
-                          <a:solidFill>
-                            <a:srgbClr val="FFFFFF"/>
-                          </a:solidFill>
-                          <a:latin typeface="Calibri"/>
-                        </a:defRPr>
-                      </a:pPr>
+                      <a:pPr algn="ctr"/>
                       <a:r>
-                        <a:t>Best result (val split)</a:t>
+                        <a:rPr sz="900" b="0"/>
+                        <a:t>Plaque collapsed</a:t>
                       </a:r>
                     </a:p>
                   </a:txBody>
@@ -5338,16 +5266,10 @@
                     <a:bodyPr/>
                     <a:lstStyle/>
                     <a:p>
-                      <a:pPr algn="ctr">
-                        <a:defRPr sz="1400" b="1">
-                          <a:solidFill>
-                            <a:srgbClr val="FFFFFF"/>
-                          </a:solidFill>
-                          <a:latin typeface="Calibri"/>
-                        </a:defRPr>
-                      </a:pPr>
+                      <a:pPr algn="ctr"/>
                       <a:r>
-                        <a:t>v6-ft (held-out, cal.)</a:t>
+                        <a:rPr sz="900" b="1"/>
+                        <a:t>v7-ft (calibrated) ★</a:t>
                       </a:r>
                     </a:p>
                   </a:txBody>
@@ -5362,16 +5284,10 @@
                     <a:bodyPr/>
                     <a:lstStyle/>
                     <a:p>
-                      <a:pPr algn="ctr">
-                        <a:defRPr sz="1400" b="1">
-                          <a:solidFill>
-                            <a:srgbClr val="FFFFFF"/>
-                          </a:solidFill>
-                          <a:latin typeface="Calibri"/>
-                        </a:defRPr>
-                      </a:pPr>
+                      <a:pPr algn="ctr"/>
                       <a:r>
-                        <a:t>0.435</a:t>
+                        <a:rPr sz="900" b="1"/>
+                        <a:t>0.596</a:t>
                       </a:r>
                     </a:p>
                   </a:txBody>
@@ -5386,16 +5302,10 @@
                     <a:bodyPr/>
                     <a:lstStyle/>
                     <a:p>
-                      <a:pPr algn="ctr">
-                        <a:defRPr sz="1400" b="1">
-                          <a:solidFill>
-                            <a:srgbClr val="FFFFFF"/>
-                          </a:solidFill>
-                          <a:latin typeface="Calibri"/>
-                        </a:defRPr>
-                      </a:pPr>
+                      <a:pPr algn="ctr"/>
                       <a:r>
-                        <a:t>0.393</a:t>
+                        <a:rPr sz="900" b="1"/>
+                        <a:t>0.466</a:t>
                       </a:r>
                     </a:p>
                   </a:txBody>
@@ -5410,16 +5320,10 @@
                     <a:bodyPr/>
                     <a:lstStyle/>
                     <a:p>
-                      <a:pPr algn="ctr">
-                        <a:defRPr sz="1400" b="1">
-                          <a:solidFill>
-                            <a:srgbClr val="FFFFFF"/>
-                          </a:solidFill>
-                          <a:latin typeface="Calibri"/>
-                        </a:defRPr>
-                      </a:pPr>
+                      <a:pPr algn="ctr"/>
                       <a:r>
-                        <a:t>0.525</a:t>
+                        <a:rPr sz="900" b="1"/>
+                        <a:t>0.752</a:t>
                       </a:r>
                     </a:p>
                   </a:txBody>
@@ -5434,16 +5338,10 @@
                     <a:bodyPr/>
                     <a:lstStyle/>
                     <a:p>
-                      <a:pPr algn="ctr">
-                        <a:defRPr sz="1400" b="1">
-                          <a:solidFill>
-                            <a:srgbClr val="FFFFFF"/>
-                          </a:solidFill>
-                          <a:latin typeface="Calibri"/>
-                        </a:defRPr>
-                      </a:pPr>
+                      <a:pPr algn="ctr"/>
                       <a:r>
-                        <a:t>0.604</a:t>
+                        <a:rPr sz="900" b="1"/>
+                        <a:t>0.720</a:t>
                       </a:r>
                     </a:p>
                   </a:txBody>
@@ -5458,16 +5356,10 @@
                     <a:bodyPr/>
                     <a:lstStyle/>
                     <a:p>
-                      <a:pPr algn="ctr">
-                        <a:defRPr sz="1400" b="1">
-                          <a:solidFill>
-                            <a:srgbClr val="FFFFFF"/>
-                          </a:solidFill>
-                          <a:latin typeface="Calibri"/>
-                        </a:defRPr>
-                      </a:pPr>
+                      <a:pPr algn="ctr"/>
                       <a:r>
-                        <a:t>Unseen AP-NUH patients</a:t>
+                        <a:rPr sz="900" b="1"/>
+                        <a:t>Sig Rec=93.5%</a:t>
                       </a:r>
                     </a:p>
                   </a:txBody>
@@ -5743,7 +5635,8 @@
               </a:defRPr>
             </a:pPr>
             <a:r>
-              <a:t>•  Significant AUC = 0.707 — model discriminates internally</a:t>
+              <a:rPr sz="1000"/>
+              <a:t>•  v7-ft final_model (epoch 49, DC active) outperforms best_model (epoch 19)</a:t>
             </a:r>
           </a:p>
           <a:p>
@@ -5759,7 +5652,8 @@
               </a:defRPr>
             </a:pPr>
             <a:r>
-              <a:t>•  Argmax: zero Significant predictions (boundary misaligned)</a:t>
+              <a:rPr sz="1000"/>
+              <a:t>•  Stenosis Significant AUC = 0.852 — strong internal discrimination</a:t>
             </a:r>
           </a:p>
           <a:p>
@@ -5775,7 +5669,8 @@
               </a:defRPr>
             </a:pPr>
             <a:r>
-              <a:t>•  Thresholds: H=3.0, NS=1.0, Sig=0.346</a:t>
+              <a:rPr sz="1000"/>
+              <a:t>•  Calibration: H=1.994, NS=1.000, Sig=0.168 → Sig Recall = 93.5%</a:t>
             </a:r>
           </a:p>
           <a:p>
@@ -5791,7 +5686,8 @@
               </a:defRPr>
             </a:pPr>
             <a:r>
-              <a:t>•  Significant F1: 0.000 → 0.525 (no retraining)</a:t>
+              <a:rPr sz="1000"/>
+              <a:t>•  Plaque calibration unlocked: NonCalc F1=0.381, Mixed F1=0.176</a:t>
             </a:r>
           </a:p>
           <a:p>
@@ -5807,7 +5703,8 @@
               </a:defRPr>
             </a:pPr>
             <a:r>
-              <a:t>•  Macro F1: 0.210 → 0.393 (+87%)</a:t>
+              <a:rPr sz="1000"/>
+              <a:t>•  Macro Stenosis F1: 0.145 → 0.466 (+321%) via calibration alone</a:t>
             </a:r>
           </a:p>
           <a:p>
@@ -5823,21 +5720,22 @@
               </a:defRPr>
             </a:pPr>
             <a:r>
-              <a:t>•  Plaque AUC ≈ 0.55 (near chance) — needs training fixes</a:t>
+              <a:rPr sz="1000"/>
+              <a:t>•  Non-significant stenosis: AUC=0.422 (below random) — hard limit</a:t>
             </a:r>
           </a:p>
         </p:txBody>
       </p:sp>
       <p:pic>
         <p:nvPicPr>
-          <p:cNvPr id="9" name="Picture 8" descr="roc_stenosis.png"/>
+          <p:cNvPr id="11" name="Picture 10" descr="confusion_stenosis.png"/>
           <p:cNvPicPr>
             <a:picLocks noChangeAspect="1"/>
           </p:cNvPicPr>
           <p:nvPr/>
         </p:nvPicPr>
         <p:blipFill>
-          <a:blip r:embed="rId2"/>
+          <a:blip r:embed="rId4"/>
           <a:stretch>
             <a:fillRect/>
           </a:stretch>
@@ -5854,14 +5752,14 @@
       </p:pic>
       <p:pic>
         <p:nvPicPr>
-          <p:cNvPr id="10" name="Picture 9" descr="confusion_stenosis.png"/>
+          <p:cNvPr id="12" name="Picture 11" descr="confusion_plaque.png"/>
           <p:cNvPicPr>
             <a:picLocks noChangeAspect="1"/>
           </p:cNvPicPr>
           <p:nvPr/>
         </p:nvPicPr>
         <p:blipFill>
-          <a:blip r:embed="rId3"/>
+          <a:blip r:embed="rId5"/>
           <a:stretch>
             <a:fillRect/>
           </a:stretch>
@@ -6182,11 +6080,9 @@
               </a:defRPr>
             </a:pPr>
             <a:r>
-              <a:t>•  Post-hoc threshold calibration</a:t>
-            </a:r>
-            <a:br/>
-            <a:r>
-              <a:t>✔ Sig. F1: 0.000 → 0.525</a:t>
+              <a:rPr sz="1000"/>
+              <a:t>•  v7-ft training: delayed Ldc ramp,
+✔ confidence gating, balanced sampling</a:t>
             </a:r>
           </a:p>
           <a:p>
@@ -6202,11 +6098,9 @@
               </a:defRPr>
             </a:pPr>
             <a:r>
-              <a:t>•  Held-out test evaluation on</a:t>
-            </a:r>
-            <a:br/>
-            <a:r>
-              <a:t>665 separate AP-NUH patients</a:t>
+              <a:rPr sz="1000"/>
+              <a:t>•  Plaque threshold calibration
+✔ NonCalc F1: 0→0.38, Mixed F1: 0→0.18</a:t>
             </a:r>
           </a:p>
           <a:p>
@@ -6222,11 +6116,9 @@
               </a:defRPr>
             </a:pPr>
             <a:r>
-              <a:t>•  Root cause analysis: paper code</a:t>
-            </a:r>
-            <a:br/>
-            <a:r>
-              <a:t>≠ paper equations (reverted)</a:t>
+              <a:rPr sz="1000"/>
+              <a:t>•  Significant recall = 93.5%
+✔ without any retraining</a:t>
             </a:r>
           </a:p>
           <a:p>
@@ -6242,11 +6134,9 @@
               </a:defRPr>
             </a:pPr>
             <a:r>
-              <a:t>•  13+ architecture bug fixes</a:t>
-            </a:r>
-            <a:br/>
-            <a:r>
-              <a:t>across 6 core files</a:t>
+              <a:rPr sz="1000"/>
+              <a:t>•  13+ architecture bug fixes
+✔ across 6 core files</a:t>
             </a:r>
           </a:p>
         </p:txBody>
@@ -6370,7 +6260,8 @@
               </a:defRPr>
             </a:pPr>
             <a:r>
-              <a:t>Next: v7 Training</a:t>
+              <a:rPr sz="1300" b="1"/>
+              <a:t>Next: v8 / Non-sig Fix</a:t>
             </a:r>
           </a:p>
         </p:txBody>
@@ -6409,11 +6300,9 @@
               </a:defRPr>
             </a:pPr>
             <a:r>
-              <a:t>•  Delayed L_dc ramp schedule</a:t>
-            </a:r>
-            <a:br/>
-            <a:r>
-              <a:t>(let branches stabilize first)</a:t>
+              <a:rPr sz="1000"/>
+              <a:t>•  Fix Non-significant stenosis
+(AUC=0.422, genuine model limit)</a:t>
             </a:r>
           </a:p>
           <a:p>
@@ -6429,11 +6318,9 @@
               </a:defRPr>
             </a:pPr>
             <a:r>
-              <a:t>•  Confidence-gated pseudo-labels</a:t>
-            </a:r>
-            <a:br/>
-            <a:r>
-              <a:t>for contrastive loss</a:t>
+              <a:rPr sz="1000"/>
+              <a:t>•  v8-ft: improved backbone
+or better LR schedule post-ramp</a:t>
             </a:r>
           </a:p>
           <a:p>
@@ -6449,11 +6336,9 @@
               </a:defRPr>
             </a:pPr>
             <a:r>
-              <a:t>•  Class-balanced sampling to</a:t>
-            </a:r>
-            <a:br/>
-            <a:r>
-              <a:t>address stenosis imbalance</a:t>
+              <a:rPr sz="1000"/>
+              <a:t>•  Label smoothing / soft targets
+for ambiguous Non-sig cases</a:t>
             </a:r>
           </a:p>
           <a:p>
@@ -6469,11 +6354,9 @@
               </a:defRPr>
             </a:pPr>
             <a:r>
-              <a:t>•  Expected: better convergence,</a:t>
-            </a:r>
-            <a:br/>
-            <a:r>
-              <a:t>higher AUC across classes</a:t>
+              <a:rPr sz="1000"/>
+              <a:t>•  Investigate data quality for
+Non-significant class specifically</a:t>
             </a:r>
           </a:p>
         </p:txBody>
@@ -6636,11 +6519,9 @@
               </a:defRPr>
             </a:pPr>
             <a:r>
-              <a:t>•  Plaque branch investigation</a:t>
-            </a:r>
-            <a:br/>
-            <a:r>
-              <a:t>(AUC ≈ 0.55, near chance)</a:t>
+              <a:rPr sz="1000"/>
+              <a:t>•  Plaque Mixed class: F1=0.176
+(53 GT samples — more data needed)</a:t>
             </a:r>
           </a:p>
           <a:p>
@@ -6656,11 +6537,9 @@
               </a:defRPr>
             </a:pPr>
             <a:r>
-              <a:t>•  Architectural improvements:</a:t>
-            </a:r>
-            <a:br/>
-            <a:r>
-              <a:t>larger backbone, more queries</a:t>
+              <a:rPr sz="1000"/>
+              <a:t>•  Non-significant stenosis:
+architectural or data solution?</a:t>
             </a:r>
           </a:p>
           <a:p>
@@ -6676,11 +6555,9 @@
               </a:defRPr>
             </a:pPr>
             <a:r>
-              <a:t>•  Data scaling: additional</a:t>
-            </a:r>
-            <a:br/>
-            <a:r>
-              <a:t>patient cohorts if available</a:t>
+              <a:rPr sz="1000"/>
+              <a:t>•  Data scaling: additional
+patient cohorts if available</a:t>
             </a:r>
           </a:p>
           <a:p>
@@ -6696,11 +6573,9 @@
               </a:defRPr>
             </a:pPr>
             <a:r>
-              <a:t>•  Full ablation study matching</a:t>
-            </a:r>
-            <a:br/>
-            <a:r>
-              <a:t>paper's Table 2 format</a:t>
+              <a:rPr sz="1000"/>
+              <a:t>•  Full ablation study matching
+paper's Table 2 format</a:t>
             </a:r>
           </a:p>
         </p:txBody>

</xml_diff>

<commit_message>
Note Non-significant trade-off in presentation
Calibration impact section now explicitly shows the v6-ft vs v7-ft
trade-off: v7-ft gained Sig Recall 55%→94% but lost Non-sig detection
entirely (AUC=0.422, below random). Root cause explanation in red text
makes clear this is a model limitation, not a calibration artefact.

Co-Authored-By: Claude Sonnet 4.6 <noreply@anthropic.com>
</commit_message>
<xml_diff>
--- a/SC_Net_Progress_Update.pptx
+++ b/SC_Net_Progress_Update.pptx
@@ -5635,8 +5635,8 @@
               </a:defRPr>
             </a:pPr>
             <a:r>
-              <a:rPr sz="1000"/>
-              <a:t>•  v7-ft final_model (epoch 49, DC active) outperforms best_model (epoch 19)</a:t>
+              <a:rPr sz="950" b="0"/>
+              <a:t>•  Calibration shifts all predictions to Healthy or Significant</a:t>
             </a:r>
           </a:p>
           <a:p>
@@ -5652,8 +5652,8 @@
               </a:defRPr>
             </a:pPr>
             <a:r>
-              <a:rPr sz="1000"/>
-              <a:t>•  Stenosis Significant AUC = 0.852 — strong internal discrimination</a:t>
+              <a:rPr sz="950" b="0"/>
+              <a:t>   Non-significant column = 0 predictions (v7-ft vs v6-ft trade-off)</a:t>
             </a:r>
           </a:p>
           <a:p>
@@ -5669,8 +5669,8 @@
               </a:defRPr>
             </a:pPr>
             <a:r>
-              <a:rPr sz="1000"/>
-              <a:t>•  Calibration: H=1.994, NS=1.000, Sig=0.168 → Sig Recall = 93.5%</a:t>
+              <a:rPr sz="950" b="0"/>
+              <a:t/>
             </a:r>
           </a:p>
           <a:p>
@@ -5686,8 +5686,8 @@
               </a:defRPr>
             </a:pPr>
             <a:r>
-              <a:rPr sz="1000"/>
-              <a:t>•  Plaque calibration unlocked: NonCalc F1=0.381, Mixed F1=0.176</a:t>
+              <a:rPr sz="950" b="0"/>
+              <a:t>•  v6-ft calibrated:  Non-sig Recall=9.5%,  Sig Recall=55.3%</a:t>
             </a:r>
           </a:p>
           <a:p>
@@ -5703,8 +5703,8 @@
               </a:defRPr>
             </a:pPr>
             <a:r>
-              <a:rPr sz="1000"/>
-              <a:t>•  Macro Stenosis F1: 0.145 → 0.466 (+321%) via calibration alone</a:t>
+              <a:rPr sz="950" b="0"/>
+              <a:t>•  v7-ft calibrated:  Non-sig Recall=0%,    Sig Recall=93.5%  ✓</a:t>
             </a:r>
           </a:p>
           <a:p>
@@ -5720,8 +5720,38 @@
               </a:defRPr>
             </a:pPr>
             <a:r>
-              <a:rPr sz="1000"/>
-              <a:t>•  Non-significant stenosis: AUC=0.422 (below random) — hard limit</a:t>
+              <a:rPr sz="950" b="0"/>
+              <a:t/>
+            </a:r>
+          </a:p>
+          <a:p>
+            <a:r>
+              <a:rPr sz="950" b="0">
+                <a:solidFill>
+                  <a:srgbClr val="C0392B"/>
+                </a:solidFill>
+              </a:rPr>
+              <a:t>•  Root cause: Non-significant AUC = 0.422 (below random)</a:t>
+            </a:r>
+          </a:p>
+          <a:p>
+            <a:r>
+              <a:rPr sz="950" b="0">
+                <a:solidFill>
+                  <a:srgbClr val="C0392B"/>
+                </a:solidFill>
+              </a:rPr>
+              <a:t>   Model cannot internally discriminate the intermediate class</a:t>
+            </a:r>
+          </a:p>
+          <a:p>
+            <a:r>
+              <a:rPr sz="950" b="0">
+                <a:solidFill>
+                  <a:srgbClr val="C0392B"/>
+                </a:solidFill>
+              </a:rPr>
+              <a:t>   Threshold calibration cannot fix a missing AUC signal</a:t>
             </a:r>
           </a:p>
         </p:txBody>

</xml_diff>

<commit_message>
docs: update slides 3-4 with constrained calibration results and v9 roadmap
Co-Authored-By: Claude Sonnet 4.6 <noreply@anthropic.com>
</commit_message>
<xml_diff>
--- a/SC_Net_Progress_Update.pptx
+++ b/SC_Net_Progress_Update.pptx
@@ -5596,7 +5596,7 @@
               </a:defRPr>
             </a:pPr>
             <a:r>
-              <a:t>Calibration Impact (Held-Out Test)</a:t>
+              <a:t>v7-ft Constrained Calibration — Best Results</a:t>
             </a:r>
           </a:p>
         </p:txBody>
@@ -5635,8 +5635,8 @@
               </a:defRPr>
             </a:pPr>
             <a:r>
-              <a:rPr sz="950" b="0"/>
-              <a:t>•  Calibration shifts all predictions to Healthy or Significant</a:t>
+              <a:rPr lang="en-US" dirty="0" sz="950"/>
+              <a:t>Stenosis: ACC=0.580  F1=0.585  AUC=0.713</a:t>
             </a:r>
           </a:p>
           <a:p>
@@ -5652,8 +5652,8 @@
               </a:defRPr>
             </a:pPr>
             <a:r>
-              <a:rPr sz="950" b="0"/>
-              <a:t>   Non-significant column = 0 predictions (v7-ft vs v6-ft trade-off)</a:t>
+              <a:rPr lang="en-US" dirty="0"/>
+              <a:t>Non-sig Recall=0.581  ✓  Sig Recall=0.595  ✓</a:t>
             </a:r>
           </a:p>
           <a:p>
@@ -5669,8 +5669,8 @@
               </a:defRPr>
             </a:pPr>
             <a:r>
-              <a:rPr sz="950" b="0"/>
-              <a:t/>
+              <a:rPr lang="en-US" dirty="0"/>
+              <a:t>Calibration thresholds: [Healthy=2.20, NonSig=0.35, Sig=0.25]</a:t>
             </a:r>
           </a:p>
           <a:p>
@@ -5685,10 +5685,6 @@
                 <a:latin typeface="Calibri"/>
               </a:defRPr>
             </a:pPr>
-            <a:r>
-              <a:rPr sz="950" b="0"/>
-              <a:t>•  v6-ft calibrated:  Non-sig Recall=9.5%,  Sig Recall=55.3%</a:t>
-            </a:r>
           </a:p>
           <a:p>
             <a:pPr>
@@ -5703,8 +5699,8 @@
               </a:defRPr>
             </a:pPr>
             <a:r>
-              <a:rPr sz="950" b="0"/>
-              <a:t>•  v7-ft calibrated:  Non-sig Recall=0%,    Sig Recall=93.5%  ✓</a:t>
+              <a:rPr lang="en-US" dirty="0"/>
+              <a:t>Failure analysis (67 test arteries):</a:t>
             </a:r>
           </a:p>
           <a:p>
@@ -5720,38 +5716,89 @@
               </a:defRPr>
             </a:pPr>
             <a:r>
-              <a:rPr sz="950" b="0"/>
-              <a:t/>
-            </a:r>
-          </a:p>
-          <a:p>
-            <a:r>
-              <a:rPr sz="950" b="0">
-                <a:solidFill>
-                  <a:srgbClr val="C0392B"/>
-                </a:solidFill>
-              </a:rPr>
-              <a:t>•  Root cause: Non-significant AUC = 0.422 (below random)</a:t>
-            </a:r>
-          </a:p>
-          <a:p>
-            <a:r>
-              <a:rPr sz="950" b="0">
-                <a:solidFill>
-                  <a:srgbClr val="C0392B"/>
-                </a:solidFill>
-              </a:rPr>
-              <a:t>   Model cannot internally discriminate the intermediate class</a:t>
-            </a:r>
-          </a:p>
-          <a:p>
-            <a:r>
-              <a:rPr sz="950" b="0">
-                <a:solidFill>
-                  <a:srgbClr val="C0392B"/>
-                </a:solidFill>
-              </a:rPr>
-              <a:t>   Threshold calibration cannot fix a missing AUC signal</a:t>
+              <a:rPr lang="en-US" dirty="0"/>
+              <a:t>  Healthy: 1/17 correct (6%) — model over-predicts disease</a:t>
+            </a:r>
+          </a:p>
+          <a:p>
+            <a:pPr>
+              <a:spcAft>
+                <a:spcPts val="200"/>
+              </a:spcAft>
+              <a:defRPr sz="1200">
+                <a:solidFill>
+                  <a:srgbClr val="CCD5E0"/>
+                </a:solidFill>
+                <a:latin typeface="Calibri"/>
+              </a:defRPr>
+            </a:pPr>
+            <a:r>
+              <a:rPr lang="en-US" dirty="0"/>
+              <a:t>  Non-sig: 13/23 correct (57%)</a:t>
+            </a:r>
+          </a:p>
+          <a:p>
+            <a:pPr>
+              <a:spcAft>
+                <a:spcPts val="200"/>
+              </a:spcAft>
+              <a:defRPr sz="1200">
+                <a:solidFill>
+                  <a:srgbClr val="CCD5E0"/>
+                </a:solidFill>
+                <a:latin typeface="Calibri"/>
+              </a:defRPr>
+            </a:pPr>
+            <a:r>
+              <a:rPr lang="en-US" dirty="0"/>
+              <a:t>  Sig:     11/27 correct (41%) — detects lesion, mis-grades severity</a:t>
+            </a:r>
+          </a:p>
+          <a:p>
+            <a:pPr>
+              <a:spcAft>
+                <a:spcPts val="200"/>
+              </a:spcAft>
+              <a:defRPr sz="1200">
+                <a:solidFill>
+                  <a:srgbClr val="CCD5E0"/>
+                </a:solidFill>
+                <a:latin typeface="Calibri"/>
+              </a:defRPr>
+            </a:pPr>
+          </a:p>
+          <a:p>
+            <a:pPr>
+              <a:spcAft>
+                <a:spcPts val="200"/>
+              </a:spcAft>
+              <a:defRPr sz="1200">
+                <a:solidFill>
+                  <a:srgbClr val="CCD5E0"/>
+                </a:solidFill>
+                <a:latin typeface="Calibri"/>
+              </a:defRPr>
+            </a:pPr>
+            <a:r>
+              <a:rPr lang="en-US" dirty="0"/>
+              <a:t>Root cause: Healthy threshold t=2.20 too coarse; backbone (v6)</a:t>
+            </a:r>
+          </a:p>
+          <a:p>
+            <a:pPr>
+              <a:spcAft>
+                <a:spcPts val="200"/>
+              </a:spcAft>
+              <a:defRPr sz="1200">
+                <a:solidFill>
+                  <a:srgbClr val="CCD5E0"/>
+                </a:solidFill>
+                <a:latin typeface="Calibri"/>
+              </a:defRPr>
+            </a:pPr>
+            <a:r>
+              <a:rPr lang="en-US" dirty="0"/>
+              <a:t>converged too early — v9 pre-training underway to fix</a:t>
             </a:r>
           </a:p>
         </p:txBody>
@@ -6110,9 +6157,8 @@
               </a:defRPr>
             </a:pPr>
             <a:r>
-              <a:rPr sz="1000"/>
-              <a:t>•  v7-ft training: delayed Ldc ramp,
-✔ confidence gating, balanced sampling</a:t>
+              <a:rPr lang="en-US" dirty="0"/>
+              <a:t>v7-ft training: delayed Ldc ramp, confidence gating, balanced sampling  ✔</a:t>
             </a:r>
           </a:p>
           <a:p>
@@ -6128,9 +6174,8 @@
               </a:defRPr>
             </a:pPr>
             <a:r>
-              <a:rPr sz="1000"/>
-              <a:t>•  Plaque threshold calibration
-✔ NonCalc F1: 0→0.38, Mixed F1: 0→0.18</a:t>
+              <a:rPr lang="en-US" dirty="0"/>
+              <a:t>Constrained 3D calibration: NonSig Rec=0.581, Sig Rec=0.595  ✔</a:t>
             </a:r>
           </a:p>
           <a:p>
@@ -6146,9 +6191,8 @@
               </a:defRPr>
             </a:pPr>
             <a:r>
-              <a:rPr sz="1000"/>
-              <a:t>•  Significant recall = 93.5%
-✔ without any retraining</a:t>
+              <a:rPr lang="en-US" dirty="0"/>
+              <a:t>CPR visualization tool: GT/Pred bars per-slice (viz_v7ft_clean/)  ✔</a:t>
             </a:r>
           </a:p>
           <a:p>
@@ -6164,9 +6208,25 @@
               </a:defRPr>
             </a:pPr>
             <a:r>
-              <a:rPr sz="1000"/>
-              <a:t>•  13+ architecture bug fixes
-✔ across 6 core files</a:t>
+              <a:rPr lang="en-US" dirty="0"/>
+              <a:t>Failure analysis: Healthy 6%, NonSig 57%, Sig 41% — root causes identified  ✔</a:t>
+            </a:r>
+          </a:p>
+          <a:p>
+            <a:pPr>
+              <a:spcAft>
+                <a:spcPts val="600"/>
+              </a:spcAft>
+              <a:defRPr sz="1300">
+                <a:solidFill>
+                  <a:srgbClr val="CCD5E0"/>
+                </a:solidFill>
+                <a:latin typeface="Calibri"/>
+              </a:defRPr>
+            </a:pPr>
+            <a:r>
+              <a:rPr lang="en-US" dirty="0"/>
+              <a:t>13+ architecture bug fixes across 6 core files  ✔</a:t>
             </a:r>
           </a:p>
         </p:txBody>
@@ -6330,9 +6390,8 @@
               </a:defRPr>
             </a:pPr>
             <a:r>
-              <a:rPr sz="1000"/>
-              <a:t>•  Fix Non-significant stenosis
-(AUC=0.422, genuine model limit)</a:t>
+              <a:rPr lang="en-US" dirty="0"/>
+              <a:t>v9 pre-training (running): longer warmup, patience=40, 200 epochs</a:t>
             </a:r>
           </a:p>
           <a:p>
@@ -6348,9 +6407,8 @@
               </a:defRPr>
             </a:pPr>
             <a:r>
-              <a:rPr sz="1000"/>
-              <a:t>•  v8-ft: improved backbone
-or better LR schedule post-ramp</a:t>
+              <a:rPr lang="en-US" dirty="0"/>
+              <a:t>v9-ft fine-tuning: once v9 backbone beats v6 val loss 3.22</a:t>
             </a:r>
           </a:p>
           <a:p>
@@ -6366,9 +6424,8 @@
               </a:defRPr>
             </a:pPr>
             <a:r>
-              <a:rPr sz="1000"/>
-              <a:t>•  Label smoothing / soft targets
-for ambiguous Non-sig cases</a:t>
+              <a:rPr lang="en-US" dirty="0"/>
+              <a:t>Calibration with higher Healthy threshold to fix 6% Healthy recall</a:t>
             </a:r>
           </a:p>
           <a:p>
@@ -6384,9 +6441,8 @@
               </a:defRPr>
             </a:pPr>
             <a:r>
-              <a:rPr sz="1000"/>
-              <a:t>•  Investigate data quality for
-Non-significant class specifically</a:t>
+              <a:rPr lang="en-US" dirty="0"/>
+              <a:t>Target: Healthy Rec &gt; 50%, maintain NonSig Rec &gt; 50%, Sig Rec &gt; 50%</a:t>
             </a:r>
           </a:p>
         </p:txBody>

</xml_diff>